<commit_message>
Fix final presentation layout
</commit_message>
<xml_diff>
--- a/docucommit-final-presentation.pptx
+++ b/docucommit-final-presentation.pptx
@@ -1875,22 +1875,22 @@
       </p:sp>
       <p:sp>
         <p:nvSpPr>
-          <p:cNvPr id="8" name="">
-            <a:extLst xmlns:a="http://schemas.openxmlformats.org/drawingml/2006/main">
-              <a:ext uri="{FF2B5EF4-FFF2-40B4-BE49-F238E27FC236}">
-                <a16:creationId xmlns:a16="http://schemas.microsoft.com/office/drawing/2014/main" id="{1956BD06-C18D-4956-9AD2-7EF045517609}"/>
-              </a:ext>
-            </a:extLst>
-          </p:cNvPr>
-          <p:cNvSpPr>
-            <a:spLocks xmlns:a="http://schemas.openxmlformats.org/drawingml/2006/main" noGrp="1"/>
-          </p:cNvSpPr>
-          <p:nvPr/>
-        </p:nvSpPr>
-        <p:spPr>
-          <a:xfrm xmlns:a="http://schemas.openxmlformats.org/drawingml/2006/main">
-            <a:off x="8172450" y="1047750"/>
-            <a:ext cx="2381250" cy="419100"/>
+          <p:cNvPr id="9" name="">
+            <a:extLst xmlns:a="http://schemas.openxmlformats.org/drawingml/2006/main">
+              <a:ext uri="{FF2B5EF4-FFF2-40B4-BE49-F238E27FC236}">
+                <a16:creationId xmlns:a16="http://schemas.microsoft.com/office/drawing/2014/main" id="{6D2F15EF-CD2E-4747-87A7-13FA12A02574}"/>
+              </a:ext>
+            </a:extLst>
+          </p:cNvPr>
+          <p:cNvSpPr>
+            <a:spLocks xmlns:a="http://schemas.openxmlformats.org/drawingml/2006/main" noGrp="1"/>
+          </p:cNvSpPr>
+          <p:nvPr/>
+        </p:nvSpPr>
+        <p:spPr>
+          <a:xfrm xmlns:a="http://schemas.openxmlformats.org/drawingml/2006/main">
+            <a:off x="7524750" y="1581150"/>
+            <a:ext cx="3143250" cy="533400"/>
           </a:xfrm>
           <a:prstGeom xmlns:a="http://schemas.openxmlformats.org/drawingml/2006/main" prst="rect">
             <a:avLst/>
@@ -1915,47 +1915,80 @@
           <a:p xmlns:a="http://schemas.openxmlformats.org/drawingml/2006/main">
             <a:pPr algn="r">
               <a:buNone/>
-              <a:defRPr sz="2850" b="1">
-                <a:solidFill>
-                  <a:srgbClr val="F1E4C8"/>
-                </a:solidFill>
-                <a:latin typeface="Aptos Display"/>
-                <a:ea typeface="Aptos Display"/>
-                <a:cs typeface="Aptos Display"/>
-              </a:defRPr>
-            </a:pPr>
-            <a:r>
-              <a:rPr sz="2850" b="1">
-                <a:solidFill>
-                  <a:srgbClr val="F1E4C8"/>
-                </a:solidFill>
-                <a:latin typeface="Aptos Display"/>
-                <a:ea typeface="Aptos Display"/>
-                <a:cs typeface="Aptos Display"/>
-              </a:rPr>
-              <a:t>5:45 target</a:t>
-            </a:r>
-          </a:p>
-        </p:txBody>
-      </p:sp>
-      <p:sp>
-        <p:nvSpPr>
-          <p:cNvPr id="9" name="">
-            <a:extLst xmlns:a="http://schemas.openxmlformats.org/drawingml/2006/main">
-              <a:ext uri="{FF2B5EF4-FFF2-40B4-BE49-F238E27FC236}">
-                <a16:creationId xmlns:a16="http://schemas.microsoft.com/office/drawing/2014/main" id="{6D2F15EF-CD2E-4747-87A7-13FA12A02574}"/>
-              </a:ext>
-            </a:extLst>
-          </p:cNvPr>
-          <p:cNvSpPr>
-            <a:spLocks xmlns:a="http://schemas.openxmlformats.org/drawingml/2006/main" noGrp="1"/>
-          </p:cNvSpPr>
-          <p:nvPr/>
-        </p:nvSpPr>
-        <p:spPr>
-          <a:xfrm xmlns:a="http://schemas.openxmlformats.org/drawingml/2006/main">
-            <a:off x="7524750" y="1581150"/>
-            <a:ext cx="3143250" cy="533400"/>
+              <a:defRPr sz="1425" b="0">
+                <a:solidFill>
+                  <a:srgbClr val="E7E0D2"/>
+                </a:solidFill>
+                <a:latin typeface="Aptos"/>
+                <a:ea typeface="Aptos"/>
+                <a:cs typeface="Aptos"/>
+              </a:defRPr>
+            </a:pPr>
+            <a:r>
+              <a:rPr sz="1425" b="0">
+                <a:solidFill>
+                  <a:srgbClr val="E7E0D2"/>
+                </a:solidFill>
+                <a:latin typeface="Aptos"/>
+                <a:ea typeface="Aptos"/>
+                <a:cs typeface="Aptos"/>
+              </a:rPr>
+              <a:t>Three feature demos, then construction lessons.</a:t>
+            </a:r>
+          </a:p>
+        </p:txBody>
+      </p:sp>
+      <p:sp>
+        <p:nvSpPr>
+          <p:cNvPr id="10" name="">
+            <a:extLst xmlns:a="http://schemas.openxmlformats.org/drawingml/2006/main">
+              <a:ext uri="{FF2B5EF4-FFF2-40B4-BE49-F238E27FC236}">
+                <a16:creationId xmlns:a16="http://schemas.microsoft.com/office/drawing/2014/main" id="{80FE97F6-5EAF-43E4-AF00-10CAE8B2C6B3}"/>
+              </a:ext>
+            </a:extLst>
+          </p:cNvPr>
+          <p:cNvSpPr>
+            <a:spLocks xmlns:a="http://schemas.openxmlformats.org/drawingml/2006/main" noGrp="1"/>
+          </p:cNvSpPr>
+          <p:nvPr/>
+        </p:nvSpPr>
+        <p:spPr>
+          <a:xfrm xmlns:a="http://schemas.openxmlformats.org/drawingml/2006/main">
+            <a:off x="7448550" y="2647950"/>
+            <a:ext cx="2857500" cy="361950"/>
+          </a:xfrm>
+          <a:prstGeom xmlns:a="http://schemas.openxmlformats.org/drawingml/2006/main" prst="rect">
+            <a:avLst/>
+          </a:prstGeom>
+          <a:solidFill xmlns:a="http://schemas.openxmlformats.org/drawingml/2006/main">
+            <a:srgbClr val="1F3C3D"/>
+          </a:solidFill>
+          <a:ln xmlns:a="http://schemas.openxmlformats.org/drawingml/2006/main" w="9525">
+            <a:solidFill>
+              <a:srgbClr val="DCECE8"/>
+            </a:solidFill>
+            <a:prstDash val="solid"/>
+          </a:ln>
+        </p:spPr>
+      </p:sp>
+      <p:sp>
+        <p:nvSpPr>
+          <p:cNvPr id="11" name="">
+            <a:extLst xmlns:a="http://schemas.openxmlformats.org/drawingml/2006/main">
+              <a:ext uri="{FF2B5EF4-FFF2-40B4-BE49-F238E27FC236}">
+                <a16:creationId xmlns:a16="http://schemas.microsoft.com/office/drawing/2014/main" id="{60FB6D91-09F2-4065-8E80-76582F94B2D2}"/>
+              </a:ext>
+            </a:extLst>
+          </p:cNvPr>
+          <p:cNvSpPr>
+            <a:spLocks xmlns:a="http://schemas.openxmlformats.org/drawingml/2006/main" noGrp="1"/>
+          </p:cNvSpPr>
+          <p:nvPr/>
+        </p:nvSpPr>
+        <p:spPr>
+          <a:xfrm xmlns:a="http://schemas.openxmlformats.org/drawingml/2006/main">
+            <a:off x="7562850" y="2695575"/>
+            <a:ext cx="2628900" cy="190500"/>
           </a:xfrm>
           <a:prstGeom xmlns:a="http://schemas.openxmlformats.org/drawingml/2006/main" prst="rect">
             <a:avLst/>
@@ -1975,84 +2008,84 @@
           </a:ln>
         </p:spPr>
         <p:txBody>
-          <a:bodyPr xmlns:a="http://schemas.openxmlformats.org/drawingml/2006/main" lIns="0" tIns="0" rIns="0" bIns="0" anchor="t"/>
-          <a:lstStyle xmlns:a="http://schemas.openxmlformats.org/drawingml/2006/main"/>
-          <a:p xmlns:a="http://schemas.openxmlformats.org/drawingml/2006/main">
-            <a:pPr algn="r">
-              <a:buNone/>
-              <a:defRPr sz="1425" b="0">
-                <a:solidFill>
-                  <a:srgbClr val="E7E0D2"/>
-                </a:solidFill>
-                <a:latin typeface="Aptos"/>
-                <a:ea typeface="Aptos"/>
-                <a:cs typeface="Aptos"/>
-              </a:defRPr>
-            </a:pPr>
-            <a:r>
-              <a:rPr sz="1425" b="0">
-                <a:solidFill>
-                  <a:srgbClr val="E7E0D2"/>
-                </a:solidFill>
-                <a:latin typeface="Aptos"/>
-                <a:ea typeface="Aptos"/>
-                <a:cs typeface="Aptos"/>
-              </a:rPr>
-              <a:t>Three feature demos, then construction lessons.</a:t>
-            </a:r>
-          </a:p>
-        </p:txBody>
-      </p:sp>
-      <p:sp>
-        <p:nvSpPr>
-          <p:cNvPr id="10" name="">
-            <a:extLst xmlns:a="http://schemas.openxmlformats.org/drawingml/2006/main">
-              <a:ext uri="{FF2B5EF4-FFF2-40B4-BE49-F238E27FC236}">
-                <a16:creationId xmlns:a16="http://schemas.microsoft.com/office/drawing/2014/main" id="{80FE97F6-5EAF-43E4-AF00-10CAE8B2C6B3}"/>
-              </a:ext>
-            </a:extLst>
-          </p:cNvPr>
-          <p:cNvSpPr>
-            <a:spLocks xmlns:a="http://schemas.openxmlformats.org/drawingml/2006/main" noGrp="1"/>
-          </p:cNvSpPr>
-          <p:nvPr/>
-        </p:nvSpPr>
-        <p:spPr>
-          <a:xfrm xmlns:a="http://schemas.openxmlformats.org/drawingml/2006/main">
-            <a:off x="7448550" y="2647950"/>
+          <a:bodyPr xmlns:a="http://schemas.openxmlformats.org/drawingml/2006/main" lIns="0" tIns="0" rIns="0" bIns="0" anchor="ctr"/>
+          <a:lstStyle xmlns:a="http://schemas.openxmlformats.org/drawingml/2006/main"/>
+          <a:p xmlns:a="http://schemas.openxmlformats.org/drawingml/2006/main">
+            <a:pPr algn="ctr">
+              <a:buNone/>
+              <a:defRPr sz="1125" b="1">
+                <a:solidFill>
+                  <a:srgbClr val="DCECE8"/>
+                </a:solidFill>
+                <a:latin typeface="Aptos"/>
+                <a:ea typeface="Aptos"/>
+                <a:cs typeface="Aptos"/>
+              </a:defRPr>
+            </a:pPr>
+            <a:r>
+              <a:rPr sz="1125" b="1">
+                <a:solidFill>
+                  <a:srgbClr val="DCECE8"/>
+                </a:solidFill>
+                <a:latin typeface="Aptos"/>
+                <a:ea typeface="Aptos"/>
+                <a:cs typeface="Aptos"/>
+              </a:rPr>
+              <a:t>1  Branch + commits</a:t>
+            </a:r>
+          </a:p>
+        </p:txBody>
+      </p:sp>
+      <p:sp>
+        <p:nvSpPr>
+          <p:cNvPr id="12" name="">
+            <a:extLst xmlns:a="http://schemas.openxmlformats.org/drawingml/2006/main">
+              <a:ext uri="{FF2B5EF4-FFF2-40B4-BE49-F238E27FC236}">
+                <a16:creationId xmlns:a16="http://schemas.microsoft.com/office/drawing/2014/main" id="{995F9B99-E8F2-49CE-B1BB-44416FEF2A76}"/>
+              </a:ext>
+            </a:extLst>
+          </p:cNvPr>
+          <p:cNvSpPr>
+            <a:spLocks xmlns:a="http://schemas.openxmlformats.org/drawingml/2006/main" noGrp="1"/>
+          </p:cNvSpPr>
+          <p:nvPr/>
+        </p:nvSpPr>
+        <p:spPr>
+          <a:xfrm xmlns:a="http://schemas.openxmlformats.org/drawingml/2006/main">
+            <a:off x="7810500" y="3143250"/>
             <a:ext cx="2857500" cy="361950"/>
           </a:xfrm>
           <a:prstGeom xmlns:a="http://schemas.openxmlformats.org/drawingml/2006/main" prst="rect">
             <a:avLst/>
           </a:prstGeom>
           <a:solidFill xmlns:a="http://schemas.openxmlformats.org/drawingml/2006/main">
-            <a:srgbClr val="1F3C3D"/>
+            <a:srgbClr val="422D2B"/>
           </a:solidFill>
           <a:ln xmlns:a="http://schemas.openxmlformats.org/drawingml/2006/main" w="9525">
             <a:solidFill>
-              <a:srgbClr val="DCECE8"/>
-            </a:solidFill>
-            <a:prstDash val="solid"/>
-          </a:ln>
-        </p:spPr>
-      </p:sp>
-      <p:sp>
-        <p:nvSpPr>
-          <p:cNvPr id="11" name="">
-            <a:extLst xmlns:a="http://schemas.openxmlformats.org/drawingml/2006/main">
-              <a:ext uri="{FF2B5EF4-FFF2-40B4-BE49-F238E27FC236}">
-                <a16:creationId xmlns:a16="http://schemas.microsoft.com/office/drawing/2014/main" id="{60FB6D91-09F2-4065-8E80-76582F94B2D2}"/>
-              </a:ext>
-            </a:extLst>
-          </p:cNvPr>
-          <p:cNvSpPr>
-            <a:spLocks xmlns:a="http://schemas.openxmlformats.org/drawingml/2006/main" noGrp="1"/>
-          </p:cNvSpPr>
-          <p:nvPr/>
-        </p:nvSpPr>
-        <p:spPr>
-          <a:xfrm xmlns:a="http://schemas.openxmlformats.org/drawingml/2006/main">
-            <a:off x="7562850" y="2695575"/>
+              <a:srgbClr val="F4DCD6"/>
+            </a:solidFill>
+            <a:prstDash val="solid"/>
+          </a:ln>
+        </p:spPr>
+      </p:sp>
+      <p:sp>
+        <p:nvSpPr>
+          <p:cNvPr id="13" name="">
+            <a:extLst xmlns:a="http://schemas.openxmlformats.org/drawingml/2006/main">
+              <a:ext uri="{FF2B5EF4-FFF2-40B4-BE49-F238E27FC236}">
+                <a16:creationId xmlns:a16="http://schemas.microsoft.com/office/drawing/2014/main" id="{8479FBAC-6AD0-4AD9-9975-E1D2494CF74B}"/>
+              </a:ext>
+            </a:extLst>
+          </p:cNvPr>
+          <p:cNvSpPr>
+            <a:spLocks xmlns:a="http://schemas.openxmlformats.org/drawingml/2006/main" noGrp="1"/>
+          </p:cNvSpPr>
+          <p:nvPr/>
+        </p:nvSpPr>
+        <p:spPr>
+          <a:xfrm xmlns:a="http://schemas.openxmlformats.org/drawingml/2006/main">
+            <a:off x="7924800" y="3190875"/>
             <a:ext cx="2628900" cy="190500"/>
           </a:xfrm>
           <a:prstGeom xmlns:a="http://schemas.openxmlformats.org/drawingml/2006/main" prst="rect">
@@ -2076,11 +2109,11 @@
           <a:bodyPr xmlns:a="http://schemas.openxmlformats.org/drawingml/2006/main" lIns="0" tIns="0" rIns="0" bIns="0" anchor="ctr"/>
           <a:lstStyle xmlns:a="http://schemas.openxmlformats.org/drawingml/2006/main"/>
           <a:p xmlns:a="http://schemas.openxmlformats.org/drawingml/2006/main">
-            <a:pPr algn="l">
+            <a:pPr algn="ctr">
               <a:buNone/>
               <a:defRPr sz="1125" b="1">
                 <a:solidFill>
-                  <a:srgbClr val="DCECE8"/>
+                  <a:srgbClr val="F4DCD6"/>
                 </a:solidFill>
                 <a:latin typeface="Aptos"/>
                 <a:ea typeface="Aptos"/>
@@ -2090,67 +2123,67 @@
             <a:r>
               <a:rPr sz="1125" b="1">
                 <a:solidFill>
-                  <a:srgbClr val="DCECE8"/>
-                </a:solidFill>
-                <a:latin typeface="Aptos"/>
-                <a:ea typeface="Aptos"/>
-                <a:cs typeface="Aptos"/>
-              </a:rPr>
-              <a:t>1  Branch + commits</a:t>
-            </a:r>
-          </a:p>
-        </p:txBody>
-      </p:sp>
-      <p:sp>
-        <p:nvSpPr>
-          <p:cNvPr id="12" name="">
-            <a:extLst xmlns:a="http://schemas.openxmlformats.org/drawingml/2006/main">
-              <a:ext uri="{FF2B5EF4-FFF2-40B4-BE49-F238E27FC236}">
-                <a16:creationId xmlns:a16="http://schemas.microsoft.com/office/drawing/2014/main" id="{995F9B99-E8F2-49CE-B1BB-44416FEF2A76}"/>
-              </a:ext>
-            </a:extLst>
-          </p:cNvPr>
-          <p:cNvSpPr>
-            <a:spLocks xmlns:a="http://schemas.openxmlformats.org/drawingml/2006/main" noGrp="1"/>
-          </p:cNvSpPr>
-          <p:nvPr/>
-        </p:nvSpPr>
-        <p:spPr>
-          <a:xfrm xmlns:a="http://schemas.openxmlformats.org/drawingml/2006/main">
-            <a:off x="7810500" y="3143250"/>
+                  <a:srgbClr val="F4DCD6"/>
+                </a:solidFill>
+                <a:latin typeface="Aptos"/>
+                <a:ea typeface="Aptos"/>
+                <a:cs typeface="Aptos"/>
+              </a:rPr>
+              <a:t>2  Visual diff engine</a:t>
+            </a:r>
+          </a:p>
+        </p:txBody>
+      </p:sp>
+      <p:sp>
+        <p:nvSpPr>
+          <p:cNvPr id="14" name="">
+            <a:extLst xmlns:a="http://schemas.openxmlformats.org/drawingml/2006/main">
+              <a:ext uri="{FF2B5EF4-FFF2-40B4-BE49-F238E27FC236}">
+                <a16:creationId xmlns:a16="http://schemas.microsoft.com/office/drawing/2014/main" id="{C3ED80B0-2867-4729-BB4C-E32309DBC8FB}"/>
+              </a:ext>
+            </a:extLst>
+          </p:cNvPr>
+          <p:cNvSpPr>
+            <a:spLocks xmlns:a="http://schemas.openxmlformats.org/drawingml/2006/main" noGrp="1"/>
+          </p:cNvSpPr>
+          <p:nvPr/>
+        </p:nvSpPr>
+        <p:spPr>
+          <a:xfrm xmlns:a="http://schemas.openxmlformats.org/drawingml/2006/main">
+            <a:off x="8172450" y="3638550"/>
             <a:ext cx="2857500" cy="361950"/>
           </a:xfrm>
           <a:prstGeom xmlns:a="http://schemas.openxmlformats.org/drawingml/2006/main" prst="rect">
             <a:avLst/>
           </a:prstGeom>
           <a:solidFill xmlns:a="http://schemas.openxmlformats.org/drawingml/2006/main">
-            <a:srgbClr val="422D2B"/>
+            <a:srgbClr val="24392D"/>
           </a:solidFill>
           <a:ln xmlns:a="http://schemas.openxmlformats.org/drawingml/2006/main" w="9525">
             <a:solidFill>
-              <a:srgbClr val="F4DCD6"/>
-            </a:solidFill>
-            <a:prstDash val="solid"/>
-          </a:ln>
-        </p:spPr>
-      </p:sp>
-      <p:sp>
-        <p:nvSpPr>
-          <p:cNvPr id="13" name="">
-            <a:extLst xmlns:a="http://schemas.openxmlformats.org/drawingml/2006/main">
-              <a:ext uri="{FF2B5EF4-FFF2-40B4-BE49-F238E27FC236}">
-                <a16:creationId xmlns:a16="http://schemas.microsoft.com/office/drawing/2014/main" id="{8479FBAC-6AD0-4AD9-9975-E1D2494CF74B}"/>
-              </a:ext>
-            </a:extLst>
-          </p:cNvPr>
-          <p:cNvSpPr>
-            <a:spLocks xmlns:a="http://schemas.openxmlformats.org/drawingml/2006/main" noGrp="1"/>
-          </p:cNvSpPr>
-          <p:nvPr/>
-        </p:nvSpPr>
-        <p:spPr>
-          <a:xfrm xmlns:a="http://schemas.openxmlformats.org/drawingml/2006/main">
-            <a:off x="7924800" y="3190875"/>
+              <a:srgbClr val="DDEBDF"/>
+            </a:solidFill>
+            <a:prstDash val="solid"/>
+          </a:ln>
+        </p:spPr>
+      </p:sp>
+      <p:sp>
+        <p:nvSpPr>
+          <p:cNvPr id="15" name="">
+            <a:extLst xmlns:a="http://schemas.openxmlformats.org/drawingml/2006/main">
+              <a:ext uri="{FF2B5EF4-FFF2-40B4-BE49-F238E27FC236}">
+                <a16:creationId xmlns:a16="http://schemas.microsoft.com/office/drawing/2014/main" id="{B6486759-81DB-4B83-BC90-B383DC05BCC6}"/>
+              </a:ext>
+            </a:extLst>
+          </p:cNvPr>
+          <p:cNvSpPr>
+            <a:spLocks xmlns:a="http://schemas.openxmlformats.org/drawingml/2006/main" noGrp="1"/>
+          </p:cNvSpPr>
+          <p:nvPr/>
+        </p:nvSpPr>
+        <p:spPr>
+          <a:xfrm xmlns:a="http://schemas.openxmlformats.org/drawingml/2006/main">
+            <a:off x="8286750" y="3686175"/>
             <a:ext cx="2628900" cy="190500"/>
           </a:xfrm>
           <a:prstGeom xmlns:a="http://schemas.openxmlformats.org/drawingml/2006/main" prst="rect">
@@ -2174,105 +2207,7 @@
           <a:bodyPr xmlns:a="http://schemas.openxmlformats.org/drawingml/2006/main" lIns="0" tIns="0" rIns="0" bIns="0" anchor="ctr"/>
           <a:lstStyle xmlns:a="http://schemas.openxmlformats.org/drawingml/2006/main"/>
           <a:p xmlns:a="http://schemas.openxmlformats.org/drawingml/2006/main">
-            <a:pPr algn="l">
-              <a:buNone/>
-              <a:defRPr sz="1125" b="1">
-                <a:solidFill>
-                  <a:srgbClr val="F4DCD6"/>
-                </a:solidFill>
-                <a:latin typeface="Aptos"/>
-                <a:ea typeface="Aptos"/>
-                <a:cs typeface="Aptos"/>
-              </a:defRPr>
-            </a:pPr>
-            <a:r>
-              <a:rPr sz="1125" b="1">
-                <a:solidFill>
-                  <a:srgbClr val="F4DCD6"/>
-                </a:solidFill>
-                <a:latin typeface="Aptos"/>
-                <a:ea typeface="Aptos"/>
-                <a:cs typeface="Aptos"/>
-              </a:rPr>
-              <a:t>2  Visual diff engine</a:t>
-            </a:r>
-          </a:p>
-        </p:txBody>
-      </p:sp>
-      <p:sp>
-        <p:nvSpPr>
-          <p:cNvPr id="14" name="">
-            <a:extLst xmlns:a="http://schemas.openxmlformats.org/drawingml/2006/main">
-              <a:ext uri="{FF2B5EF4-FFF2-40B4-BE49-F238E27FC236}">
-                <a16:creationId xmlns:a16="http://schemas.microsoft.com/office/drawing/2014/main" id="{C3ED80B0-2867-4729-BB4C-E32309DBC8FB}"/>
-              </a:ext>
-            </a:extLst>
-          </p:cNvPr>
-          <p:cNvSpPr>
-            <a:spLocks xmlns:a="http://schemas.openxmlformats.org/drawingml/2006/main" noGrp="1"/>
-          </p:cNvSpPr>
-          <p:nvPr/>
-        </p:nvSpPr>
-        <p:spPr>
-          <a:xfrm xmlns:a="http://schemas.openxmlformats.org/drawingml/2006/main">
-            <a:off x="8172450" y="3638550"/>
-            <a:ext cx="2857500" cy="361950"/>
-          </a:xfrm>
-          <a:prstGeom xmlns:a="http://schemas.openxmlformats.org/drawingml/2006/main" prst="rect">
-            <a:avLst/>
-          </a:prstGeom>
-          <a:solidFill xmlns:a="http://schemas.openxmlformats.org/drawingml/2006/main">
-            <a:srgbClr val="24392D"/>
-          </a:solidFill>
-          <a:ln xmlns:a="http://schemas.openxmlformats.org/drawingml/2006/main" w="9525">
-            <a:solidFill>
-              <a:srgbClr val="DDEBDF"/>
-            </a:solidFill>
-            <a:prstDash val="solid"/>
-          </a:ln>
-        </p:spPr>
-      </p:sp>
-      <p:sp>
-        <p:nvSpPr>
-          <p:cNvPr id="15" name="">
-            <a:extLst xmlns:a="http://schemas.openxmlformats.org/drawingml/2006/main">
-              <a:ext uri="{FF2B5EF4-FFF2-40B4-BE49-F238E27FC236}">
-                <a16:creationId xmlns:a16="http://schemas.microsoft.com/office/drawing/2014/main" id="{B6486759-81DB-4B83-BC90-B383DC05BCC6}"/>
-              </a:ext>
-            </a:extLst>
-          </p:cNvPr>
-          <p:cNvSpPr>
-            <a:spLocks xmlns:a="http://schemas.openxmlformats.org/drawingml/2006/main" noGrp="1"/>
-          </p:cNvSpPr>
-          <p:nvPr/>
-        </p:nvSpPr>
-        <p:spPr>
-          <a:xfrm xmlns:a="http://schemas.openxmlformats.org/drawingml/2006/main">
-            <a:off x="8286750" y="3686175"/>
-            <a:ext cx="2628900" cy="190500"/>
-          </a:xfrm>
-          <a:prstGeom xmlns:a="http://schemas.openxmlformats.org/drawingml/2006/main" prst="rect">
-            <a:avLst/>
-          </a:prstGeom>
-          <a:solidFill xmlns:a="http://schemas.openxmlformats.org/drawingml/2006/main">
-            <a:srgbClr val="000000">
-              <a:alpha val="0"/>
-            </a:srgbClr>
-          </a:solidFill>
-          <a:ln xmlns:a="http://schemas.openxmlformats.org/drawingml/2006/main" w="0">
-            <a:solidFill>
-              <a:srgbClr val="000000">
-                <a:alpha val="0"/>
-              </a:srgbClr>
-            </a:solidFill>
-            <a:prstDash val="solid"/>
-          </a:ln>
-        </p:spPr>
-        <p:txBody>
-          <a:bodyPr xmlns:a="http://schemas.openxmlformats.org/drawingml/2006/main" lIns="0" tIns="0" rIns="0" bIns="0" anchor="ctr"/>
-          <a:lstStyle xmlns:a="http://schemas.openxmlformats.org/drawingml/2006/main"/>
-          <a:p xmlns:a="http://schemas.openxmlformats.org/drawingml/2006/main">
-            <a:pPr algn="l">
+            <a:pPr algn="ctr">
               <a:buNone/>
               <a:defRPr sz="1125" b="1">
                 <a:solidFill>
@@ -2857,7 +2792,7 @@
           <a:bodyPr xmlns:a="http://schemas.openxmlformats.org/drawingml/2006/main" lIns="0" tIns="0" rIns="0" bIns="0" anchor="ctr"/>
           <a:lstStyle xmlns:a="http://schemas.openxmlformats.org/drawingml/2006/main"/>
           <a:p xmlns:a="http://schemas.openxmlformats.org/drawingml/2006/main">
-            <a:pPr algn="l">
+            <a:pPr algn="ctr">
               <a:buNone/>
               <a:defRPr sz="1200" b="1">
                 <a:solidFill>
@@ -3020,7 +2955,7 @@
           <a:bodyPr xmlns:a="http://schemas.openxmlformats.org/drawingml/2006/main" lIns="0" tIns="0" rIns="0" bIns="0" anchor="ctr"/>
           <a:lstStyle xmlns:a="http://schemas.openxmlformats.org/drawingml/2006/main"/>
           <a:p xmlns:a="http://schemas.openxmlformats.org/drawingml/2006/main">
-            <a:pPr algn="l">
+            <a:pPr algn="ctr">
               <a:buNone/>
               <a:defRPr sz="1200" b="1">
                 <a:solidFill>
@@ -3183,7 +3118,7 @@
           <a:bodyPr xmlns:a="http://schemas.openxmlformats.org/drawingml/2006/main" lIns="0" tIns="0" rIns="0" bIns="0" anchor="ctr"/>
           <a:lstStyle xmlns:a="http://schemas.openxmlformats.org/drawingml/2006/main"/>
           <a:p xmlns:a="http://schemas.openxmlformats.org/drawingml/2006/main">
-            <a:pPr algn="l">
+            <a:pPr algn="ctr">
               <a:buNone/>
               <a:defRPr sz="1200" b="1">
                 <a:solidFill>
@@ -3346,7 +3281,7 @@
           <a:bodyPr xmlns:a="http://schemas.openxmlformats.org/drawingml/2006/main" lIns="0" tIns="0" rIns="0" bIns="0" anchor="ctr"/>
           <a:lstStyle xmlns:a="http://schemas.openxmlformats.org/drawingml/2006/main"/>
           <a:p xmlns:a="http://schemas.openxmlformats.org/drawingml/2006/main">
-            <a:pPr algn="l">
+            <a:pPr algn="ctr">
               <a:buNone/>
               <a:defRPr sz="1200" b="1">
                 <a:solidFill>
@@ -3509,7 +3444,7 @@
           <a:bodyPr xmlns:a="http://schemas.openxmlformats.org/drawingml/2006/main" lIns="0" tIns="0" rIns="0" bIns="0" anchor="ctr"/>
           <a:lstStyle xmlns:a="http://schemas.openxmlformats.org/drawingml/2006/main"/>
           <a:p xmlns:a="http://schemas.openxmlformats.org/drawingml/2006/main">
-            <a:pPr algn="l">
+            <a:pPr algn="ctr">
               <a:buNone/>
               <a:defRPr sz="1200" b="1">
                 <a:solidFill>
@@ -3737,7 +3672,7 @@
           <a:bodyPr xmlns:a="http://schemas.openxmlformats.org/drawingml/2006/main" lIns="0" tIns="0" rIns="0" bIns="0" anchor="ctr"/>
           <a:lstStyle xmlns:a="http://schemas.openxmlformats.org/drawingml/2006/main"/>
           <a:p xmlns:a="http://schemas.openxmlformats.org/drawingml/2006/main">
-            <a:pPr algn="l">
+            <a:pPr algn="ctr">
               <a:buNone/>
               <a:defRPr sz="900" b="1">
                 <a:solidFill>
@@ -3835,7 +3770,7 @@
           <a:bodyPr xmlns:a="http://schemas.openxmlformats.org/drawingml/2006/main" lIns="0" tIns="0" rIns="0" bIns="0" anchor="ctr"/>
           <a:lstStyle xmlns:a="http://schemas.openxmlformats.org/drawingml/2006/main"/>
           <a:p xmlns:a="http://schemas.openxmlformats.org/drawingml/2006/main">
-            <a:pPr algn="l">
+            <a:pPr algn="ctr">
               <a:buNone/>
               <a:defRPr sz="900" b="1">
                 <a:solidFill>
@@ -3933,7 +3868,7 @@
           <a:bodyPr xmlns:a="http://schemas.openxmlformats.org/drawingml/2006/main" lIns="0" tIns="0" rIns="0" bIns="0" anchor="ctr"/>
           <a:lstStyle xmlns:a="http://schemas.openxmlformats.org/drawingml/2006/main"/>
           <a:p xmlns:a="http://schemas.openxmlformats.org/drawingml/2006/main">
-            <a:pPr algn="l">
+            <a:pPr algn="ctr">
               <a:buNone/>
               <a:defRPr sz="900" b="1">
                 <a:solidFill>
@@ -4319,406 +4254,6 @@
                 <a:cs typeface="Aptos"/>
               </a:rPr>
               <a:t>Lessons come from real integration tradeoffs.</a:t>
-            </a:r>
-          </a:p>
-        </p:txBody>
-      </p:sp>
-      <p:sp>
-        <p:nvSpPr>
-          <p:cNvPr id="35" name="">
-            <a:extLst xmlns:a="http://schemas.openxmlformats.org/drawingml/2006/main">
-              <a:ext uri="{FF2B5EF4-FFF2-40B4-BE49-F238E27FC236}">
-                <a16:creationId xmlns:a16="http://schemas.microsoft.com/office/drawing/2014/main" id="{0812C50E-8FFD-4FE2-9867-960DE32D5897}"/>
-              </a:ext>
-            </a:extLst>
-          </p:cNvPr>
-          <p:cNvSpPr>
-            <a:spLocks xmlns:a="http://schemas.openxmlformats.org/drawingml/2006/main" noGrp="1"/>
-          </p:cNvSpPr>
-          <p:nvPr/>
-        </p:nvSpPr>
-        <p:spPr>
-          <a:xfrm xmlns:a="http://schemas.openxmlformats.org/drawingml/2006/main">
-            <a:off x="723900" y="4972050"/>
-            <a:ext cx="1714500" cy="266700"/>
-          </a:xfrm>
-          <a:prstGeom xmlns:a="http://schemas.openxmlformats.org/drawingml/2006/main" prst="rect">
-            <a:avLst/>
-          </a:prstGeom>
-          <a:solidFill xmlns:a="http://schemas.openxmlformats.org/drawingml/2006/main">
-            <a:srgbClr val="000000">
-              <a:alpha val="0"/>
-            </a:srgbClr>
-          </a:solidFill>
-          <a:ln xmlns:a="http://schemas.openxmlformats.org/drawingml/2006/main" w="0">
-            <a:solidFill>
-              <a:srgbClr val="000000">
-                <a:alpha val="0"/>
-              </a:srgbClr>
-            </a:solidFill>
-            <a:prstDash val="solid"/>
-          </a:ln>
-        </p:spPr>
-        <p:txBody>
-          <a:bodyPr xmlns:a="http://schemas.openxmlformats.org/drawingml/2006/main" lIns="0" tIns="0" rIns="0" bIns="0" anchor="t"/>
-          <a:lstStyle xmlns:a="http://schemas.openxmlformats.org/drawingml/2006/main"/>
-          <a:p xmlns:a="http://schemas.openxmlformats.org/drawingml/2006/main">
-            <a:pPr algn="l">
-              <a:buNone/>
-              <a:defRPr sz="1500" b="1">
-                <a:solidFill>
-                  <a:srgbClr val="222831"/>
-                </a:solidFill>
-                <a:latin typeface="Aptos"/>
-                <a:ea typeface="Aptos"/>
-                <a:cs typeface="Aptos"/>
-              </a:defRPr>
-            </a:pPr>
-            <a:r>
-              <a:rPr sz="1500" b="1">
-                <a:solidFill>
-                  <a:srgbClr val="222831"/>
-                </a:solidFill>
-                <a:latin typeface="Aptos"/>
-                <a:ea typeface="Aptos"/>
-                <a:cs typeface="Aptos"/>
-              </a:rPr>
-              <a:t>Timing target</a:t>
-            </a:r>
-          </a:p>
-        </p:txBody>
-      </p:sp>
-      <p:sp>
-        <p:nvSpPr>
-          <p:cNvPr id="36" name="">
-            <a:extLst xmlns:a="http://schemas.openxmlformats.org/drawingml/2006/main">
-              <a:ext uri="{FF2B5EF4-FFF2-40B4-BE49-F238E27FC236}">
-                <a16:creationId xmlns:a16="http://schemas.microsoft.com/office/drawing/2014/main" id="{12C0582E-A6E1-4AA1-8917-6A692DC33F71}"/>
-              </a:ext>
-            </a:extLst>
-          </p:cNvPr>
-          <p:cNvSpPr>
-            <a:spLocks xmlns:a="http://schemas.openxmlformats.org/drawingml/2006/main" noGrp="1"/>
-          </p:cNvSpPr>
-          <p:nvPr/>
-        </p:nvSpPr>
-        <p:spPr>
-          <a:xfrm xmlns:a="http://schemas.openxmlformats.org/drawingml/2006/main">
-            <a:off x="723900" y="5448300"/>
-            <a:ext cx="9620250" cy="95250"/>
-          </a:xfrm>
-          <a:prstGeom xmlns:a="http://schemas.openxmlformats.org/drawingml/2006/main" prst="rect">
-            <a:avLst/>
-          </a:prstGeom>
-          <a:solidFill xmlns:a="http://schemas.openxmlformats.org/drawingml/2006/main">
-            <a:srgbClr val="D8D1C4"/>
-          </a:solidFill>
-          <a:ln xmlns:a="http://schemas.openxmlformats.org/drawingml/2006/main" w="0">
-            <a:solidFill>
-              <a:srgbClr val="000000">
-                <a:alpha val="0"/>
-              </a:srgbClr>
-            </a:solidFill>
-            <a:prstDash val="solid"/>
-          </a:ln>
-        </p:spPr>
-      </p:sp>
-      <p:sp>
-        <p:nvSpPr>
-          <p:cNvPr id="37" name="">
-            <a:extLst xmlns:a="http://schemas.openxmlformats.org/drawingml/2006/main">
-              <a:ext uri="{FF2B5EF4-FFF2-40B4-BE49-F238E27FC236}">
-                <a16:creationId xmlns:a16="http://schemas.microsoft.com/office/drawing/2014/main" id="{F6712662-97A7-4E23-91E0-4B844BDEDB01}"/>
-              </a:ext>
-            </a:extLst>
-          </p:cNvPr>
-          <p:cNvSpPr>
-            <a:spLocks xmlns:a="http://schemas.openxmlformats.org/drawingml/2006/main" noGrp="1"/>
-          </p:cNvSpPr>
-          <p:nvPr/>
-        </p:nvSpPr>
-        <p:spPr>
-          <a:xfrm xmlns:a="http://schemas.openxmlformats.org/drawingml/2006/main">
-            <a:off x="723900" y="5448300"/>
-            <a:ext cx="1571625" cy="95250"/>
-          </a:xfrm>
-          <a:prstGeom xmlns:a="http://schemas.openxmlformats.org/drawingml/2006/main" prst="rect">
-            <a:avLst/>
-          </a:prstGeom>
-          <a:solidFill xmlns:a="http://schemas.openxmlformats.org/drawingml/2006/main">
-            <a:srgbClr val="3B5B8A"/>
-          </a:solidFill>
-          <a:ln xmlns:a="http://schemas.openxmlformats.org/drawingml/2006/main" w="0">
-            <a:solidFill>
-              <a:srgbClr val="000000">
-                <a:alpha val="0"/>
-              </a:srgbClr>
-            </a:solidFill>
-            <a:prstDash val="solid"/>
-          </a:ln>
-        </p:spPr>
-      </p:sp>
-      <p:sp>
-        <p:nvSpPr>
-          <p:cNvPr id="38" name="">
-            <a:extLst xmlns:a="http://schemas.openxmlformats.org/drawingml/2006/main">
-              <a:ext uri="{FF2B5EF4-FFF2-40B4-BE49-F238E27FC236}">
-                <a16:creationId xmlns:a16="http://schemas.microsoft.com/office/drawing/2014/main" id="{C46A64A5-4572-49D9-BB97-96F5393BD5C9}"/>
-              </a:ext>
-            </a:extLst>
-          </p:cNvPr>
-          <p:cNvSpPr>
-            <a:spLocks xmlns:a="http://schemas.openxmlformats.org/drawingml/2006/main" noGrp="1"/>
-          </p:cNvSpPr>
-          <p:nvPr/>
-        </p:nvSpPr>
-        <p:spPr>
-          <a:xfrm xmlns:a="http://schemas.openxmlformats.org/drawingml/2006/main">
-            <a:off x="2295525" y="5448300"/>
-            <a:ext cx="4714875" cy="95250"/>
-          </a:xfrm>
-          <a:prstGeom xmlns:a="http://schemas.openxmlformats.org/drawingml/2006/main" prst="rect">
-            <a:avLst/>
-          </a:prstGeom>
-          <a:solidFill xmlns:a="http://schemas.openxmlformats.org/drawingml/2006/main">
-            <a:srgbClr val="146C6C"/>
-          </a:solidFill>
-          <a:ln xmlns:a="http://schemas.openxmlformats.org/drawingml/2006/main" w="0">
-            <a:solidFill>
-              <a:srgbClr val="000000">
-                <a:alpha val="0"/>
-              </a:srgbClr>
-            </a:solidFill>
-            <a:prstDash val="solid"/>
-          </a:ln>
-        </p:spPr>
-      </p:sp>
-      <p:sp>
-        <p:nvSpPr>
-          <p:cNvPr id="39" name="">
-            <a:extLst xmlns:a="http://schemas.openxmlformats.org/drawingml/2006/main">
-              <a:ext uri="{FF2B5EF4-FFF2-40B4-BE49-F238E27FC236}">
-                <a16:creationId xmlns:a16="http://schemas.microsoft.com/office/drawing/2014/main" id="{B3BEB2E2-3BBC-492F-86ED-00A7C2527067}"/>
-              </a:ext>
-            </a:extLst>
-          </p:cNvPr>
-          <p:cNvSpPr>
-            <a:spLocks xmlns:a="http://schemas.openxmlformats.org/drawingml/2006/main" noGrp="1"/>
-          </p:cNvSpPr>
-          <p:nvPr/>
-        </p:nvSpPr>
-        <p:spPr>
-          <a:xfrm xmlns:a="http://schemas.openxmlformats.org/drawingml/2006/main">
-            <a:off x="7010400" y="5448300"/>
-            <a:ext cx="2857500" cy="95250"/>
-          </a:xfrm>
-          <a:prstGeom xmlns:a="http://schemas.openxmlformats.org/drawingml/2006/main" prst="rect">
-            <a:avLst/>
-          </a:prstGeom>
-          <a:solidFill xmlns:a="http://schemas.openxmlformats.org/drawingml/2006/main">
-            <a:srgbClr val="B7832F"/>
-          </a:solidFill>
-          <a:ln xmlns:a="http://schemas.openxmlformats.org/drawingml/2006/main" w="0">
-            <a:solidFill>
-              <a:srgbClr val="000000">
-                <a:alpha val="0"/>
-              </a:srgbClr>
-            </a:solidFill>
-            <a:prstDash val="solid"/>
-          </a:ln>
-        </p:spPr>
-      </p:sp>
-      <p:sp>
-        <p:nvSpPr>
-          <p:cNvPr id="40" name="">
-            <a:extLst xmlns:a="http://schemas.openxmlformats.org/drawingml/2006/main">
-              <a:ext uri="{FF2B5EF4-FFF2-40B4-BE49-F238E27FC236}">
-                <a16:creationId xmlns:a16="http://schemas.microsoft.com/office/drawing/2014/main" id="{07923B8C-AEC3-43C5-8149-56E8572DDCC7}"/>
-              </a:ext>
-            </a:extLst>
-          </p:cNvPr>
-          <p:cNvSpPr>
-            <a:spLocks xmlns:a="http://schemas.openxmlformats.org/drawingml/2006/main" noGrp="1"/>
-          </p:cNvSpPr>
-          <p:nvPr/>
-        </p:nvSpPr>
-        <p:spPr>
-          <a:xfrm xmlns:a="http://schemas.openxmlformats.org/drawingml/2006/main">
-            <a:off x="723900" y="5619750"/>
-            <a:ext cx="1428750" cy="228600"/>
-          </a:xfrm>
-          <a:prstGeom xmlns:a="http://schemas.openxmlformats.org/drawingml/2006/main" prst="rect">
-            <a:avLst/>
-          </a:prstGeom>
-          <a:solidFill xmlns:a="http://schemas.openxmlformats.org/drawingml/2006/main">
-            <a:srgbClr val="000000">
-              <a:alpha val="0"/>
-            </a:srgbClr>
-          </a:solidFill>
-          <a:ln xmlns:a="http://schemas.openxmlformats.org/drawingml/2006/main" w="0">
-            <a:solidFill>
-              <a:srgbClr val="000000">
-                <a:alpha val="0"/>
-              </a:srgbClr>
-            </a:solidFill>
-            <a:prstDash val="solid"/>
-          </a:ln>
-        </p:spPr>
-        <p:txBody>
-          <a:bodyPr xmlns:a="http://schemas.openxmlformats.org/drawingml/2006/main" lIns="0" tIns="0" rIns="0" bIns="0" anchor="t"/>
-          <a:lstStyle xmlns:a="http://schemas.openxmlformats.org/drawingml/2006/main"/>
-          <a:p xmlns:a="http://schemas.openxmlformats.org/drawingml/2006/main">
-            <a:pPr algn="l">
-              <a:buNone/>
-              <a:defRPr sz="975" b="0">
-                <a:solidFill>
-                  <a:srgbClr val="6B665F"/>
-                </a:solidFill>
-                <a:latin typeface="Aptos"/>
-                <a:ea typeface="Aptos"/>
-                <a:cs typeface="Aptos"/>
-              </a:defRPr>
-            </a:pPr>
-            <a:r>
-              <a:rPr sz="975" b="0">
-                <a:solidFill>
-                  <a:srgbClr val="6B665F"/>
-                </a:solidFill>
-                <a:latin typeface="Aptos"/>
-                <a:ea typeface="Aptos"/>
-                <a:cs typeface="Aptos"/>
-              </a:rPr>
-              <a:t>0:25 setup</a:t>
-            </a:r>
-          </a:p>
-        </p:txBody>
-      </p:sp>
-      <p:sp>
-        <p:nvSpPr>
-          <p:cNvPr id="41" name="">
-            <a:extLst xmlns:a="http://schemas.openxmlformats.org/drawingml/2006/main">
-              <a:ext uri="{FF2B5EF4-FFF2-40B4-BE49-F238E27FC236}">
-                <a16:creationId xmlns:a16="http://schemas.microsoft.com/office/drawing/2014/main" id="{FAE1BB40-0D45-4F9B-ABA2-65141E8851B4}"/>
-              </a:ext>
-            </a:extLst>
-          </p:cNvPr>
-          <p:cNvSpPr>
-            <a:spLocks xmlns:a="http://schemas.openxmlformats.org/drawingml/2006/main" noGrp="1"/>
-          </p:cNvSpPr>
-          <p:nvPr/>
-        </p:nvSpPr>
-        <p:spPr>
-          <a:xfrm xmlns:a="http://schemas.openxmlformats.org/drawingml/2006/main">
-            <a:off x="3714750" y="5619750"/>
-            <a:ext cx="1714500" cy="228600"/>
-          </a:xfrm>
-          <a:prstGeom xmlns:a="http://schemas.openxmlformats.org/drawingml/2006/main" prst="rect">
-            <a:avLst/>
-          </a:prstGeom>
-          <a:solidFill xmlns:a="http://schemas.openxmlformats.org/drawingml/2006/main">
-            <a:srgbClr val="000000">
-              <a:alpha val="0"/>
-            </a:srgbClr>
-          </a:solidFill>
-          <a:ln xmlns:a="http://schemas.openxmlformats.org/drawingml/2006/main" w="0">
-            <a:solidFill>
-              <a:srgbClr val="000000">
-                <a:alpha val="0"/>
-              </a:srgbClr>
-            </a:solidFill>
-            <a:prstDash val="solid"/>
-          </a:ln>
-        </p:spPr>
-        <p:txBody>
-          <a:bodyPr xmlns:a="http://schemas.openxmlformats.org/drawingml/2006/main" lIns="0" tIns="0" rIns="0" bIns="0" anchor="t"/>
-          <a:lstStyle xmlns:a="http://schemas.openxmlformats.org/drawingml/2006/main"/>
-          <a:p xmlns:a="http://schemas.openxmlformats.org/drawingml/2006/main">
-            <a:pPr algn="ctr">
-              <a:buNone/>
-              <a:defRPr sz="975" b="0">
-                <a:solidFill>
-                  <a:srgbClr val="6B665F"/>
-                </a:solidFill>
-                <a:latin typeface="Aptos"/>
-                <a:ea typeface="Aptos"/>
-                <a:cs typeface="Aptos"/>
-              </a:defRPr>
-            </a:pPr>
-            <a:r>
-              <a:rPr sz="975" b="0">
-                <a:solidFill>
-                  <a:srgbClr val="6B665F"/>
-                </a:solidFill>
-                <a:latin typeface="Aptos"/>
-                <a:ea typeface="Aptos"/>
-                <a:cs typeface="Aptos"/>
-              </a:rPr>
-              <a:t>3:00 feature demo</a:t>
-            </a:r>
-          </a:p>
-        </p:txBody>
-      </p:sp>
-      <p:sp>
-        <p:nvSpPr>
-          <p:cNvPr id="42" name="">
-            <a:extLst xmlns:a="http://schemas.openxmlformats.org/drawingml/2006/main">
-              <a:ext uri="{FF2B5EF4-FFF2-40B4-BE49-F238E27FC236}">
-                <a16:creationId xmlns:a16="http://schemas.microsoft.com/office/drawing/2014/main" id="{45BF775A-16C7-4DC1-AA54-5B085228443A}"/>
-              </a:ext>
-            </a:extLst>
-          </p:cNvPr>
-          <p:cNvSpPr>
-            <a:spLocks xmlns:a="http://schemas.openxmlformats.org/drawingml/2006/main" noGrp="1"/>
-          </p:cNvSpPr>
-          <p:nvPr/>
-        </p:nvSpPr>
-        <p:spPr>
-          <a:xfrm xmlns:a="http://schemas.openxmlformats.org/drawingml/2006/main">
-            <a:off x="7924800" y="5619750"/>
-            <a:ext cx="2286000" cy="228600"/>
-          </a:xfrm>
-          <a:prstGeom xmlns:a="http://schemas.openxmlformats.org/drawingml/2006/main" prst="rect">
-            <a:avLst/>
-          </a:prstGeom>
-          <a:solidFill xmlns:a="http://schemas.openxmlformats.org/drawingml/2006/main">
-            <a:srgbClr val="000000">
-              <a:alpha val="0"/>
-            </a:srgbClr>
-          </a:solidFill>
-          <a:ln xmlns:a="http://schemas.openxmlformats.org/drawingml/2006/main" w="0">
-            <a:solidFill>
-              <a:srgbClr val="000000">
-                <a:alpha val="0"/>
-              </a:srgbClr>
-            </a:solidFill>
-            <a:prstDash val="solid"/>
-          </a:ln>
-        </p:spPr>
-        <p:txBody>
-          <a:bodyPr xmlns:a="http://schemas.openxmlformats.org/drawingml/2006/main" lIns="0" tIns="0" rIns="0" bIns="0" anchor="t"/>
-          <a:lstStyle xmlns:a="http://schemas.openxmlformats.org/drawingml/2006/main"/>
-          <a:p xmlns:a="http://schemas.openxmlformats.org/drawingml/2006/main">
-            <a:pPr algn="ctr">
-              <a:buNone/>
-              <a:defRPr sz="975" b="0">
-                <a:solidFill>
-                  <a:srgbClr val="6B665F"/>
-                </a:solidFill>
-                <a:latin typeface="Aptos"/>
-                <a:ea typeface="Aptos"/>
-                <a:cs typeface="Aptos"/>
-              </a:defRPr>
-            </a:pPr>
-            <a:r>
-              <a:rPr sz="975" b="0">
-                <a:solidFill>
-                  <a:srgbClr val="6B665F"/>
-                </a:solidFill>
-                <a:latin typeface="Aptos"/>
-                <a:ea typeface="Aptos"/>
-                <a:cs typeface="Aptos"/>
-              </a:rPr>
-              <a:t>1:50 lessons + contributions</a:t>
             </a:r>
           </a:p>
         </p:txBody>
@@ -5316,7 +4851,7 @@
           <a:bodyPr xmlns:a="http://schemas.openxmlformats.org/drawingml/2006/main" lIns="0" tIns="0" rIns="0" bIns="0" anchor="ctr"/>
           <a:lstStyle xmlns:a="http://schemas.openxmlformats.org/drawingml/2006/main"/>
           <a:p xmlns:a="http://schemas.openxmlformats.org/drawingml/2006/main">
-            <a:pPr algn="l">
+            <a:pPr algn="ctr">
               <a:buNone/>
               <a:defRPr sz="1125" b="1">
                 <a:solidFill>
@@ -5340,7 +4875,7 @@
             </a:r>
           </a:p>
           <a:p xmlns:a="http://schemas.openxmlformats.org/drawingml/2006/main">
-            <a:pPr algn="l">
+            <a:pPr algn="ctr">
               <a:buNone/>
               <a:defRPr sz="1125" b="1">
                 <a:solidFill>
@@ -5438,7 +4973,7 @@
           <a:bodyPr xmlns:a="http://schemas.openxmlformats.org/drawingml/2006/main" lIns="0" tIns="0" rIns="0" bIns="0" anchor="ctr"/>
           <a:lstStyle xmlns:a="http://schemas.openxmlformats.org/drawingml/2006/main"/>
           <a:p xmlns:a="http://schemas.openxmlformats.org/drawingml/2006/main">
-            <a:pPr algn="l">
+            <a:pPr algn="ctr">
               <a:buNone/>
               <a:defRPr sz="1125" b="1">
                 <a:solidFill>
@@ -5462,7 +4997,7 @@
             </a:r>
           </a:p>
           <a:p xmlns:a="http://schemas.openxmlformats.org/drawingml/2006/main">
-            <a:pPr algn="l">
+            <a:pPr algn="ctr">
               <a:buNone/>
               <a:defRPr sz="1125" b="1">
                 <a:solidFill>
@@ -5630,7 +5165,7 @@
           <a:bodyPr xmlns:a="http://schemas.openxmlformats.org/drawingml/2006/main" lIns="0" tIns="0" rIns="0" bIns="0" anchor="ctr"/>
           <a:lstStyle xmlns:a="http://schemas.openxmlformats.org/drawingml/2006/main"/>
           <a:p xmlns:a="http://schemas.openxmlformats.org/drawingml/2006/main">
-            <a:pPr algn="l">
+            <a:pPr algn="ctr">
               <a:buNone/>
               <a:defRPr sz="1125" b="1">
                 <a:solidFill>
@@ -5654,7 +5189,7 @@
             </a:r>
           </a:p>
           <a:p xmlns:a="http://schemas.openxmlformats.org/drawingml/2006/main">
-            <a:pPr algn="l">
+            <a:pPr algn="ctr">
               <a:buNone/>
               <a:defRPr sz="1125" b="1">
                 <a:solidFill>
@@ -5752,7 +5287,7 @@
           <a:bodyPr xmlns:a="http://schemas.openxmlformats.org/drawingml/2006/main" lIns="0" tIns="0" rIns="0" bIns="0" anchor="ctr"/>
           <a:lstStyle xmlns:a="http://schemas.openxmlformats.org/drawingml/2006/main"/>
           <a:p xmlns:a="http://schemas.openxmlformats.org/drawingml/2006/main">
-            <a:pPr algn="l">
+            <a:pPr algn="ctr">
               <a:buNone/>
               <a:defRPr sz="1125" b="1">
                 <a:solidFill>
@@ -5776,7 +5311,7 @@
             </a:r>
           </a:p>
           <a:p xmlns:a="http://schemas.openxmlformats.org/drawingml/2006/main">
-            <a:pPr algn="l">
+            <a:pPr algn="ctr">
               <a:buNone/>
               <a:defRPr sz="1125" b="1">
                 <a:solidFill>
@@ -6892,8 +6427,8 @@
         </p:nvSpPr>
         <p:spPr>
           <a:xfrm xmlns:a="http://schemas.openxmlformats.org/drawingml/2006/main">
-            <a:off x="8020050" y="5276850"/>
-            <a:ext cx="2857500" cy="476250"/>
+            <a:off x="8020050" y="5162550"/>
+            <a:ext cx="2857500" cy="685800"/>
           </a:xfrm>
           <a:prstGeom xmlns:a="http://schemas.openxmlformats.org/drawingml/2006/main" prst="rect">
             <a:avLst/>
@@ -6925,7 +6460,7 @@
         </p:nvSpPr>
         <p:spPr>
           <a:xfrm xmlns:a="http://schemas.openxmlformats.org/drawingml/2006/main">
-            <a:off x="8172450" y="5353050"/>
+            <a:off x="8172450" y="5276850"/>
             <a:ext cx="1066800" cy="190500"/>
           </a:xfrm>
           <a:prstGeom xmlns:a="http://schemas.openxmlformats.org/drawingml/2006/main" prst="rect">
@@ -6990,8 +6525,8 @@
         </p:nvSpPr>
         <p:spPr>
           <a:xfrm xmlns:a="http://schemas.openxmlformats.org/drawingml/2006/main">
-            <a:off x="8172450" y="5543550"/>
-            <a:ext cx="2552700" cy="190500"/>
+            <a:off x="8172450" y="5486400"/>
+            <a:ext cx="2552700" cy="342900"/>
           </a:xfrm>
           <a:prstGeom xmlns:a="http://schemas.openxmlformats.org/drawingml/2006/main" prst="rect">
             <a:avLst/>
@@ -8350,7 +7885,7 @@
           <a:bodyPr xmlns:a="http://schemas.openxmlformats.org/drawingml/2006/main" lIns="0" tIns="0" rIns="0" bIns="0" anchor="ctr"/>
           <a:lstStyle xmlns:a="http://schemas.openxmlformats.org/drawingml/2006/main"/>
           <a:p xmlns:a="http://schemas.openxmlformats.org/drawingml/2006/main">
-            <a:pPr algn="l">
+            <a:pPr algn="ctr">
               <a:buNone/>
               <a:defRPr sz="975" b="1">
                 <a:solidFill>
@@ -9453,7 +8988,7 @@
           <a:bodyPr xmlns:a="http://schemas.openxmlformats.org/drawingml/2006/main" lIns="0" tIns="0" rIns="0" bIns="0" anchor="ctr"/>
           <a:lstStyle xmlns:a="http://schemas.openxmlformats.org/drawingml/2006/main"/>
           <a:p xmlns:a="http://schemas.openxmlformats.org/drawingml/2006/main">
-            <a:pPr algn="l">
+            <a:pPr algn="ctr">
               <a:buNone/>
               <a:defRPr sz="1125" b="1">
                 <a:solidFill>
@@ -9477,7 +9012,7 @@
             </a:r>
           </a:p>
           <a:p xmlns:a="http://schemas.openxmlformats.org/drawingml/2006/main">
-            <a:pPr algn="l">
+            <a:pPr algn="ctr">
               <a:buNone/>
               <a:defRPr sz="1125" b="1">
                 <a:solidFill>
@@ -9575,7 +9110,7 @@
           <a:bodyPr xmlns:a="http://schemas.openxmlformats.org/drawingml/2006/main" lIns="0" tIns="0" rIns="0" bIns="0" anchor="ctr"/>
           <a:lstStyle xmlns:a="http://schemas.openxmlformats.org/drawingml/2006/main"/>
           <a:p xmlns:a="http://schemas.openxmlformats.org/drawingml/2006/main">
-            <a:pPr algn="l">
+            <a:pPr algn="ctr">
               <a:buNone/>
               <a:defRPr sz="1125" b="1">
                 <a:solidFill>
@@ -9599,7 +9134,7 @@
             </a:r>
           </a:p>
           <a:p xmlns:a="http://schemas.openxmlformats.org/drawingml/2006/main">
-            <a:pPr algn="l">
+            <a:pPr algn="ctr">
               <a:buNone/>
               <a:defRPr sz="1125" b="1">
                 <a:solidFill>
@@ -9697,7 +9232,7 @@
           <a:bodyPr xmlns:a="http://schemas.openxmlformats.org/drawingml/2006/main" lIns="0" tIns="0" rIns="0" bIns="0" anchor="ctr"/>
           <a:lstStyle xmlns:a="http://schemas.openxmlformats.org/drawingml/2006/main"/>
           <a:p xmlns:a="http://schemas.openxmlformats.org/drawingml/2006/main">
-            <a:pPr algn="l">
+            <a:pPr algn="ctr">
               <a:buNone/>
               <a:defRPr sz="1125" b="1">
                 <a:solidFill>
@@ -9721,7 +9256,7 @@
             </a:r>
           </a:p>
           <a:p xmlns:a="http://schemas.openxmlformats.org/drawingml/2006/main">
-            <a:pPr algn="l">
+            <a:pPr algn="ctr">
               <a:buNone/>
               <a:defRPr sz="1125" b="1">
                 <a:solidFill>
@@ -10029,7 +9564,7 @@
           <a:bodyPr xmlns:a="http://schemas.openxmlformats.org/drawingml/2006/main" lIns="0" tIns="0" rIns="0" bIns="0" anchor="ctr"/>
           <a:lstStyle xmlns:a="http://schemas.openxmlformats.org/drawingml/2006/main"/>
           <a:p xmlns:a="http://schemas.openxmlformats.org/drawingml/2006/main">
-            <a:pPr algn="l">
+            <a:pPr algn="ctr">
               <a:buNone/>
               <a:defRPr sz="1050" b="1">
                 <a:solidFill>
@@ -10053,7 +9588,7 @@
             </a:r>
           </a:p>
           <a:p xmlns:a="http://schemas.openxmlformats.org/drawingml/2006/main">
-            <a:pPr algn="l">
+            <a:pPr algn="ctr">
               <a:buNone/>
               <a:defRPr sz="1050" b="1">
                 <a:solidFill>
@@ -10522,7 +10057,7 @@
           <a:bodyPr xmlns:a="http://schemas.openxmlformats.org/drawingml/2006/main" lIns="0" tIns="0" rIns="0" bIns="0" anchor="ctr"/>
           <a:lstStyle xmlns:a="http://schemas.openxmlformats.org/drawingml/2006/main"/>
           <a:p xmlns:a="http://schemas.openxmlformats.org/drawingml/2006/main">
-            <a:pPr algn="l">
+            <a:pPr algn="ctr">
               <a:buNone/>
               <a:defRPr sz="1125" b="1">
                 <a:solidFill>
@@ -11170,7 +10705,7 @@
           <a:bodyPr xmlns:a="http://schemas.openxmlformats.org/drawingml/2006/main" lIns="0" tIns="0" rIns="0" bIns="0" anchor="ctr"/>
           <a:lstStyle xmlns:a="http://schemas.openxmlformats.org/drawingml/2006/main"/>
           <a:p xmlns:a="http://schemas.openxmlformats.org/drawingml/2006/main">
-            <a:pPr algn="l">
+            <a:pPr algn="ctr">
               <a:buNone/>
               <a:defRPr sz="1050" b="1">
                 <a:solidFill>
@@ -11194,7 +10729,7 @@
             </a:r>
           </a:p>
           <a:p xmlns:a="http://schemas.openxmlformats.org/drawingml/2006/main">
-            <a:pPr algn="l">
+            <a:pPr algn="ctr">
               <a:buNone/>
               <a:defRPr sz="1050" b="1">
                 <a:solidFill>
@@ -11218,7 +10753,7 @@
             </a:r>
           </a:p>
           <a:p xmlns:a="http://schemas.openxmlformats.org/drawingml/2006/main">
-            <a:pPr algn="l">
+            <a:pPr algn="ctr">
               <a:buNone/>
               <a:defRPr sz="1050" b="1">
                 <a:solidFill>
@@ -11316,7 +10851,7 @@
           <a:bodyPr xmlns:a="http://schemas.openxmlformats.org/drawingml/2006/main" lIns="0" tIns="0" rIns="0" bIns="0" anchor="ctr"/>
           <a:lstStyle xmlns:a="http://schemas.openxmlformats.org/drawingml/2006/main"/>
           <a:p xmlns:a="http://schemas.openxmlformats.org/drawingml/2006/main">
-            <a:pPr algn="l">
+            <a:pPr algn="ctr">
               <a:buNone/>
               <a:defRPr sz="1050" b="1">
                 <a:solidFill>
@@ -11340,7 +10875,7 @@
             </a:r>
           </a:p>
           <a:p xmlns:a="http://schemas.openxmlformats.org/drawingml/2006/main">
-            <a:pPr algn="l">
+            <a:pPr algn="ctr">
               <a:buNone/>
               <a:defRPr sz="1050" b="1">
                 <a:solidFill>
@@ -11364,7 +10899,7 @@
             </a:r>
           </a:p>
           <a:p xmlns:a="http://schemas.openxmlformats.org/drawingml/2006/main">
-            <a:pPr algn="l">
+            <a:pPr algn="ctr">
               <a:buNone/>
               <a:defRPr sz="1050" b="1">
                 <a:solidFill>
@@ -11462,7 +10997,7 @@
           <a:bodyPr xmlns:a="http://schemas.openxmlformats.org/drawingml/2006/main" lIns="0" tIns="0" rIns="0" bIns="0" anchor="ctr"/>
           <a:lstStyle xmlns:a="http://schemas.openxmlformats.org/drawingml/2006/main"/>
           <a:p xmlns:a="http://schemas.openxmlformats.org/drawingml/2006/main">
-            <a:pPr algn="l">
+            <a:pPr algn="ctr">
               <a:buNone/>
               <a:defRPr sz="1050" b="1">
                 <a:solidFill>
@@ -11486,7 +11021,7 @@
             </a:r>
           </a:p>
           <a:p xmlns:a="http://schemas.openxmlformats.org/drawingml/2006/main">
-            <a:pPr algn="l">
+            <a:pPr algn="ctr">
               <a:buNone/>
               <a:defRPr sz="1050" b="1">
                 <a:solidFill>
@@ -11510,7 +11045,7 @@
             </a:r>
           </a:p>
           <a:p xmlns:a="http://schemas.openxmlformats.org/drawingml/2006/main">
-            <a:pPr algn="l">
+            <a:pPr algn="ctr">
               <a:buNone/>
               <a:defRPr sz="1050" b="1">
                 <a:solidFill>
@@ -11678,7 +11213,7 @@
           <a:bodyPr xmlns:a="http://schemas.openxmlformats.org/drawingml/2006/main" lIns="0" tIns="0" rIns="0" bIns="0" anchor="ctr"/>
           <a:lstStyle xmlns:a="http://schemas.openxmlformats.org/drawingml/2006/main"/>
           <a:p xmlns:a="http://schemas.openxmlformats.org/drawingml/2006/main">
-            <a:pPr algn="l">
+            <a:pPr algn="ctr">
               <a:buNone/>
               <a:defRPr sz="1050" b="1">
                 <a:solidFill>
@@ -11702,7 +11237,7 @@
             </a:r>
           </a:p>
           <a:p xmlns:a="http://schemas.openxmlformats.org/drawingml/2006/main">
-            <a:pPr algn="l">
+            <a:pPr algn="ctr">
               <a:buNone/>
               <a:defRPr sz="1050" b="1">
                 <a:solidFill>
@@ -11726,7 +11261,7 @@
             </a:r>
           </a:p>
           <a:p xmlns:a="http://schemas.openxmlformats.org/drawingml/2006/main">
-            <a:pPr algn="l">
+            <a:pPr algn="ctr">
               <a:buNone/>
               <a:defRPr sz="1050" b="1">
                 <a:solidFill>

</xml_diff>